<commit_message>
docs(pitch): add system-architecture slide to tech deck + rewrite script
Replaced the stack-chips slide with a system architecture diagram
showing the three zones (Agent · Ayni · Lightning + Contributors)
with three numbered arrows for the request, payment, and fan-out flows.
The Ayni middle container shows all four internal components (manifest,
API route + L402, splitter, dashboard).

Script rewritten so slide 2 is the centerpiece — speaker points at each
zone of the diagram. Re-timed all six slides:
  hero (0:00-0:08), arch (0:08-0:25), L402 zoom (0:25-0:35),
  splitter (0:35-0:46), fix (0:46-0:55), closing (0:55-1:00)

Co-Authored-By: Claude Opus 4.7 (1M context) <noreply@anthropic.com>
</commit_message>
<xml_diff>
--- a/ayni-pitch/Ayni-tech-deck.pptx
+++ b/ayni-pitch/Ayni-tech-deck.pptx
@@ -3180,7 +3180,7 @@
                 </a:solidFill>
                 <a:latin typeface="Consolas"/>
               </a:rPr>
-              <a:t>0:00 – 0:10</a:t>
+              <a:t>0:00 – 0:08</a:t>
             </a:r>
           </a:p>
         </p:txBody>
@@ -3446,7 +3446,7 @@
                 </a:solidFill>
                 <a:latin typeface="Consolas"/>
               </a:rPr>
-              <a:t>0:10 – 0:18</a:t>
+              <a:t>0:08 – 0:25</a:t>
             </a:r>
           </a:p>
         </p:txBody>
@@ -3503,7 +3503,7 @@
         <p:spPr>
           <a:xfrm>
             <a:off x="777240" y="640080"/>
-            <a:ext cx="4572000" cy="457200"/>
+            <a:ext cx="5486400" cy="457200"/>
           </a:xfrm>
           <a:prstGeom prst="rect">
             <a:avLst/>
@@ -3528,7 +3528,7 @@
                 </a:solidFill>
                 <a:latin typeface="Calibri"/>
               </a:rPr>
-              <a:t>STACK</a:t>
+              <a:t>SYSTEM ARCHITECTURE</a:t>
             </a:r>
           </a:p>
         </p:txBody>
@@ -3541,8 +3541,8 @@
         </p:nvSpPr>
         <p:spPr>
           <a:xfrm>
-            <a:off x="548640" y="1371600"/>
-            <a:ext cx="11091672" cy="914400"/>
+            <a:off x="548640" y="1234440"/>
+            <a:ext cx="11091672" cy="822960"/>
           </a:xfrm>
           <a:prstGeom prst="rect">
             <a:avLst/>
@@ -3561,13 +3561,13 @@
               </a:lnSpc>
             </a:pPr>
             <a:r>
-              <a:rPr sz="4400" b="1" i="0">
+              <a:rPr sz="3400" b="1" i="0">
                 <a:solidFill>
                   <a:srgbClr val="ECECF0"/>
                 </a:solidFill>
                 <a:latin typeface="Calibri"/>
               </a:rPr>
-              <a:t>What we built it on.</a:t>
+              <a:t>How it fits together.</a:t>
             </a:r>
           </a:p>
         </p:txBody>
@@ -3580,8 +3580,8 @@
         </p:nvSpPr>
         <p:spPr>
           <a:xfrm>
-            <a:off x="548640" y="2834640"/>
-            <a:ext cx="5362956" cy="1463040"/>
+            <a:off x="548640" y="3200400"/>
+            <a:ext cx="2103120" cy="2194560"/>
           </a:xfrm>
           <a:prstGeom prst="roundRect">
             <a:avLst>
@@ -3625,8 +3625,8 @@
         </p:nvSpPr>
         <p:spPr>
           <a:xfrm>
-            <a:off x="914400" y="3063240"/>
-            <a:ext cx="4631436" cy="640080"/>
+            <a:off x="548640" y="3520440"/>
+            <a:ext cx="2103120" cy="548640"/>
           </a:xfrm>
           <a:prstGeom prst="rect">
             <a:avLst/>
@@ -3639,19 +3639,19 @@
           </a:bodyPr>
           <a:lstStyle/>
           <a:p>
-            <a:pPr algn="l">
+            <a:pPr algn="ctr">
               <a:lnSpc>
                 <a:spcPct val="100000"/>
               </a:lnSpc>
             </a:pPr>
             <a:r>
-              <a:rPr sz="3000" b="1" i="0">
+              <a:rPr sz="2200" b="1" i="0">
                 <a:solidFill>
                   <a:srgbClr val="F7931A"/>
                 </a:solidFill>
                 <a:latin typeface="Calibri"/>
               </a:rPr>
-              <a:t>Next.js 15</a:t>
+              <a:t>AI Agent</a:t>
             </a:r>
           </a:p>
         </p:txBody>
@@ -3664,8 +3664,8 @@
         </p:nvSpPr>
         <p:spPr>
           <a:xfrm>
-            <a:off x="914400" y="3703320"/>
-            <a:ext cx="4631436" cy="457200"/>
+            <a:off x="548640" y="4114800"/>
+            <a:ext cx="2103120" cy="457200"/>
           </a:xfrm>
           <a:prstGeom prst="rect">
             <a:avLst/>
@@ -3678,33 +3678,886 @@
           </a:bodyPr>
           <a:lstStyle/>
           <a:p>
+            <a:pPr algn="ctr">
+              <a:lnSpc>
+                <a:spcPct val="100000"/>
+              </a:lnSpc>
+            </a:pPr>
+            <a:r>
+              <a:rPr sz="1600" b="0" i="0">
+                <a:solidFill>
+                  <a:srgbClr val="ECECF0"/>
+                </a:solidFill>
+                <a:latin typeface="Calibri"/>
+              </a:rPr>
+              <a:t>+ wallet</a:t>
+            </a:r>
+          </a:p>
+        </p:txBody>
+      </p:sp>
+      <p:sp>
+        <p:nvSpPr>
+          <p:cNvPr id="10" name="TextBox 9"/>
+          <p:cNvSpPr txBox="1"/>
+          <p:nvPr/>
+        </p:nvSpPr>
+        <p:spPr>
+          <a:xfrm>
+            <a:off x="548640" y="4617720"/>
+            <a:ext cx="2103120" cy="640080"/>
+          </a:xfrm>
+          <a:prstGeom prst="rect">
+            <a:avLst/>
+          </a:prstGeom>
+          <a:noFill/>
+        </p:spPr>
+        <p:txBody>
+          <a:bodyPr wrap="square" lIns="0" rIns="0" tIns="0" bIns="0">
+            <a:spAutoFit/>
+          </a:bodyPr>
+          <a:lstStyle/>
+          <a:p>
+            <a:pPr algn="ctr">
+              <a:lnSpc>
+                <a:spcPct val="130000"/>
+              </a:lnSpc>
+            </a:pPr>
+            <a:r>
+              <a:rPr sz="1000" b="0" i="0">
+                <a:solidFill>
+                  <a:srgbClr val="8B93A7"/>
+                </a:solidFill>
+                <a:latin typeface="Consolas"/>
+              </a:rPr>
+              <a:t>MDK · Phoenix</a:t>
+            </a:r>
+          </a:p>
+          <a:p>
+            <a:pPr algn="ctr">
+              <a:lnSpc>
+                <a:spcPct val="130000"/>
+              </a:lnSpc>
+            </a:pPr>
+            <a:r>
+              <a:rPr sz="1000" b="0" i="0">
+                <a:solidFill>
+                  <a:srgbClr val="8B93A7"/>
+                </a:solidFill>
+                <a:latin typeface="Consolas"/>
+              </a:rPr>
+              <a:t>Alby · Strike</a:t>
+            </a:r>
+          </a:p>
+        </p:txBody>
+      </p:sp>
+      <p:sp>
+        <p:nvSpPr>
+          <p:cNvPr id="11" name="Rounded Rectangle 10"/>
+          <p:cNvSpPr/>
+          <p:nvPr/>
+        </p:nvSpPr>
+        <p:spPr>
+          <a:xfrm>
+            <a:off x="3200400" y="2331720"/>
+            <a:ext cx="5394960" cy="3931920"/>
+          </a:xfrm>
+          <a:prstGeom prst="roundRect">
+            <a:avLst>
+              <a:gd name="adj" fmla="val 4000"/>
+            </a:avLst>
+          </a:prstGeom>
+          <a:solidFill>
+            <a:srgbClr val="182138"/>
+          </a:solidFill>
+          <a:ln w="12700">
+            <a:solidFill>
+              <a:srgbClr val="F7931A"/>
+            </a:solidFill>
+          </a:ln>
+        </p:spPr>
+        <p:style>
+          <a:lnRef idx="1">
+            <a:schemeClr val="accent1"/>
+          </a:lnRef>
+          <a:fillRef idx="3">
+            <a:schemeClr val="accent1"/>
+          </a:fillRef>
+          <a:effectRef idx="2">
+            <a:schemeClr val="accent1"/>
+          </a:effectRef>
+          <a:fontRef idx="minor">
+            <a:schemeClr val="lt1"/>
+          </a:fontRef>
+        </p:style>
+        <p:txBody>
+          <a:bodyPr rtlCol="0" anchor="ctr"/>
+          <a:lstStyle/>
+          <a:p>
+            <a:pPr algn="ctr"/>
+          </a:p>
+        </p:txBody>
+      </p:sp>
+      <p:sp>
+        <p:nvSpPr>
+          <p:cNvPr id="12" name="TextBox 11"/>
+          <p:cNvSpPr txBox="1"/>
+          <p:nvPr/>
+        </p:nvSpPr>
+        <p:spPr>
+          <a:xfrm>
+            <a:off x="3383280" y="2468880"/>
+            <a:ext cx="5029200" cy="457200"/>
+          </a:xfrm>
+          <a:prstGeom prst="rect">
+            <a:avLst/>
+          </a:prstGeom>
+          <a:noFill/>
+        </p:spPr>
+        <p:txBody>
+          <a:bodyPr wrap="square" lIns="0" rIns="0" tIns="0" bIns="0" anchor="ctr">
+            <a:spAutoFit/>
+          </a:bodyPr>
+          <a:lstStyle/>
+          <a:p>
+            <a:pPr algn="ctr">
+              <a:lnSpc>
+                <a:spcPct val="100000"/>
+              </a:lnSpc>
+            </a:pPr>
+            <a:r>
+              <a:rPr sz="1400" b="1" i="0">
+                <a:solidFill>
+                  <a:srgbClr val="F7931A"/>
+                </a:solidFill>
+                <a:latin typeface="Calibri"/>
+              </a:rPr>
+              <a:t>Ayni  —  Next.js 15 on Vercel</a:t>
+            </a:r>
+          </a:p>
+        </p:txBody>
+      </p:sp>
+      <p:sp>
+        <p:nvSpPr>
+          <p:cNvPr id="13" name="Rounded Rectangle 12"/>
+          <p:cNvSpPr/>
+          <p:nvPr/>
+        </p:nvSpPr>
+        <p:spPr>
+          <a:xfrm>
+            <a:off x="3429000" y="3017520"/>
+            <a:ext cx="2377440" cy="1440179"/>
+          </a:xfrm>
+          <a:prstGeom prst="roundRect">
+            <a:avLst>
+              <a:gd name="adj" fmla="val 6000"/>
+            </a:avLst>
+          </a:prstGeom>
+          <a:solidFill>
+            <a:srgbClr val="222D4A"/>
+          </a:solidFill>
+          <a:ln>
+            <a:noFill/>
+          </a:ln>
+        </p:spPr>
+        <p:style>
+          <a:lnRef idx="1">
+            <a:schemeClr val="accent1"/>
+          </a:lnRef>
+          <a:fillRef idx="3">
+            <a:schemeClr val="accent1"/>
+          </a:fillRef>
+          <a:effectRef idx="2">
+            <a:schemeClr val="accent1"/>
+          </a:effectRef>
+          <a:fontRef idx="minor">
+            <a:schemeClr val="lt1"/>
+          </a:fontRef>
+        </p:style>
+        <p:txBody>
+          <a:bodyPr rtlCol="0" anchor="ctr"/>
+          <a:lstStyle/>
+          <a:p>
+            <a:pPr algn="ctr"/>
+          </a:p>
+        </p:txBody>
+      </p:sp>
+      <p:sp>
+        <p:nvSpPr>
+          <p:cNvPr id="14" name="TextBox 13"/>
+          <p:cNvSpPr txBox="1"/>
+          <p:nvPr/>
+        </p:nvSpPr>
+        <p:spPr>
+          <a:xfrm>
+            <a:off x="3611880" y="3154680"/>
+            <a:ext cx="2011680" cy="365760"/>
+          </a:xfrm>
+          <a:prstGeom prst="rect">
+            <a:avLst/>
+          </a:prstGeom>
+          <a:noFill/>
+        </p:spPr>
+        <p:txBody>
+          <a:bodyPr wrap="square" lIns="0" rIns="0" tIns="0" bIns="0">
+            <a:spAutoFit/>
+          </a:bodyPr>
+          <a:lstStyle/>
+          <a:p>
             <a:pPr algn="l">
               <a:lnSpc>
                 <a:spcPct val="100000"/>
               </a:lnSpc>
             </a:pPr>
             <a:r>
-              <a:rPr sz="1400" b="0" i="0">
-                <a:solidFill>
-                  <a:srgbClr val="8B93A7"/>
+              <a:rPr sz="1500" b="1" i="0">
+                <a:solidFill>
+                  <a:srgbClr val="ECECF0"/>
+                </a:solidFill>
+                <a:latin typeface="Calibri"/>
+              </a:rPr>
+              <a:t>manifest</a:t>
+            </a:r>
+          </a:p>
+        </p:txBody>
+      </p:sp>
+      <p:sp>
+        <p:nvSpPr>
+          <p:cNvPr id="15" name="TextBox 14"/>
+          <p:cNvSpPr txBox="1"/>
+          <p:nvPr/>
+        </p:nvSpPr>
+        <p:spPr>
+          <a:xfrm>
+            <a:off x="3611880" y="3520440"/>
+            <a:ext cx="2011680" cy="274320"/>
+          </a:xfrm>
+          <a:prstGeom prst="rect">
+            <a:avLst/>
+          </a:prstGeom>
+          <a:noFill/>
+        </p:spPr>
+        <p:txBody>
+          <a:bodyPr wrap="square" lIns="0" rIns="0" tIns="0" bIns="0">
+            <a:spAutoFit/>
+          </a:bodyPr>
+          <a:lstStyle/>
+          <a:p>
+            <a:pPr algn="l">
+              <a:lnSpc>
+                <a:spcPct val="100000"/>
+              </a:lnSpc>
+            </a:pPr>
+            <a:r>
+              <a:rPr sz="1000" b="0" i="1">
+                <a:solidFill>
+                  <a:srgbClr val="F7931A"/>
+                </a:solidFill>
+                <a:latin typeface="Calibri"/>
+              </a:rPr>
+              <a:t>discovery</a:t>
+            </a:r>
+          </a:p>
+        </p:txBody>
+      </p:sp>
+      <p:sp>
+        <p:nvSpPr>
+          <p:cNvPr id="16" name="TextBox 15"/>
+          <p:cNvSpPr txBox="1"/>
+          <p:nvPr/>
+        </p:nvSpPr>
+        <p:spPr>
+          <a:xfrm>
+            <a:off x="3611880" y="3794760"/>
+            <a:ext cx="2011680" cy="571499"/>
+          </a:xfrm>
+          <a:prstGeom prst="rect">
+            <a:avLst/>
+          </a:prstGeom>
+          <a:noFill/>
+        </p:spPr>
+        <p:txBody>
+          <a:bodyPr wrap="square" lIns="0" rIns="0" tIns="0" bIns="0">
+            <a:spAutoFit/>
+          </a:bodyPr>
+          <a:lstStyle/>
+          <a:p>
+            <a:pPr algn="l">
+              <a:lnSpc>
+                <a:spcPct val="130000"/>
+              </a:lnSpc>
+            </a:pPr>
+            <a:r>
+              <a:rPr sz="1000" b="0" i="0">
+                <a:solidFill>
+                  <a:srgbClr val="FFD580"/>
                 </a:solidFill>
                 <a:latin typeface="Consolas"/>
               </a:rPr>
-              <a:t>App Router · React 19 · Vercel</a:t>
-            </a:r>
-          </a:p>
-        </p:txBody>
-      </p:sp>
-      <p:sp>
-        <p:nvSpPr>
-          <p:cNvPr id="10" name="Rounded Rectangle 9"/>
+              <a:t>/.well-known/</a:t>
+            </a:r>
+          </a:p>
+          <a:p>
+            <a:pPr algn="l">
+              <a:lnSpc>
+                <a:spcPct val="130000"/>
+              </a:lnSpc>
+            </a:pPr>
+            <a:r>
+              <a:rPr sz="1000" b="0" i="0">
+                <a:solidFill>
+                  <a:srgbClr val="FFD580"/>
+                </a:solidFill>
+                <a:latin typeface="Consolas"/>
+              </a:rPr>
+              <a:t>agent-skill.json</a:t>
+            </a:r>
+          </a:p>
+        </p:txBody>
+      </p:sp>
+      <p:sp>
+        <p:nvSpPr>
+          <p:cNvPr id="17" name="Rounded Rectangle 16"/>
           <p:cNvSpPr/>
           <p:nvPr/>
         </p:nvSpPr>
         <p:spPr>
           <a:xfrm>
-            <a:off x="6277356" y="2834640"/>
-            <a:ext cx="5362956" cy="1463040"/>
+            <a:off x="5989320" y="3017520"/>
+            <a:ext cx="2377440" cy="1440179"/>
+          </a:xfrm>
+          <a:prstGeom prst="roundRect">
+            <a:avLst>
+              <a:gd name="adj" fmla="val 6000"/>
+            </a:avLst>
+          </a:prstGeom>
+          <a:solidFill>
+            <a:srgbClr val="222D4A"/>
+          </a:solidFill>
+          <a:ln>
+            <a:noFill/>
+          </a:ln>
+        </p:spPr>
+        <p:style>
+          <a:lnRef idx="1">
+            <a:schemeClr val="accent1"/>
+          </a:lnRef>
+          <a:fillRef idx="3">
+            <a:schemeClr val="accent1"/>
+          </a:fillRef>
+          <a:effectRef idx="2">
+            <a:schemeClr val="accent1"/>
+          </a:effectRef>
+          <a:fontRef idx="minor">
+            <a:schemeClr val="lt1"/>
+          </a:fontRef>
+        </p:style>
+        <p:txBody>
+          <a:bodyPr rtlCol="0" anchor="ctr"/>
+          <a:lstStyle/>
+          <a:p>
+            <a:pPr algn="ctr"/>
+          </a:p>
+        </p:txBody>
+      </p:sp>
+      <p:sp>
+        <p:nvSpPr>
+          <p:cNvPr id="18" name="TextBox 17"/>
+          <p:cNvSpPr txBox="1"/>
+          <p:nvPr/>
+        </p:nvSpPr>
+        <p:spPr>
+          <a:xfrm>
+            <a:off x="6172200" y="3154680"/>
+            <a:ext cx="2011680" cy="365760"/>
+          </a:xfrm>
+          <a:prstGeom prst="rect">
+            <a:avLst/>
+          </a:prstGeom>
+          <a:noFill/>
+        </p:spPr>
+        <p:txBody>
+          <a:bodyPr wrap="square" lIns="0" rIns="0" tIns="0" bIns="0">
+            <a:spAutoFit/>
+          </a:bodyPr>
+          <a:lstStyle/>
+          <a:p>
+            <a:pPr algn="l">
+              <a:lnSpc>
+                <a:spcPct val="100000"/>
+              </a:lnSpc>
+            </a:pPr>
+            <a:r>
+              <a:rPr sz="1500" b="1" i="0">
+                <a:solidFill>
+                  <a:srgbClr val="ECECF0"/>
+                </a:solidFill>
+                <a:latin typeface="Calibri"/>
+              </a:rPr>
+              <a:t>API route</a:t>
+            </a:r>
+          </a:p>
+        </p:txBody>
+      </p:sp>
+      <p:sp>
+        <p:nvSpPr>
+          <p:cNvPr id="19" name="TextBox 18"/>
+          <p:cNvSpPr txBox="1"/>
+          <p:nvPr/>
+        </p:nvSpPr>
+        <p:spPr>
+          <a:xfrm>
+            <a:off x="6172200" y="3520440"/>
+            <a:ext cx="2011680" cy="274320"/>
+          </a:xfrm>
+          <a:prstGeom prst="rect">
+            <a:avLst/>
+          </a:prstGeom>
+          <a:noFill/>
+        </p:spPr>
+        <p:txBody>
+          <a:bodyPr wrap="square" lIns="0" rIns="0" tIns="0" bIns="0">
+            <a:spAutoFit/>
+          </a:bodyPr>
+          <a:lstStyle/>
+          <a:p>
+            <a:pPr algn="l">
+              <a:lnSpc>
+                <a:spcPct val="100000"/>
+              </a:lnSpc>
+            </a:pPr>
+            <a:r>
+              <a:rPr sz="1000" b="0" i="1">
+                <a:solidFill>
+                  <a:srgbClr val="F7931A"/>
+                </a:solidFill>
+                <a:latin typeface="Calibri"/>
+              </a:rPr>
+              <a:t>L402 paywall</a:t>
+            </a:r>
+          </a:p>
+        </p:txBody>
+      </p:sp>
+      <p:sp>
+        <p:nvSpPr>
+          <p:cNvPr id="20" name="TextBox 19"/>
+          <p:cNvSpPr txBox="1"/>
+          <p:nvPr/>
+        </p:nvSpPr>
+        <p:spPr>
+          <a:xfrm>
+            <a:off x="6172200" y="3794760"/>
+            <a:ext cx="2011680" cy="571499"/>
+          </a:xfrm>
+          <a:prstGeom prst="rect">
+            <a:avLst/>
+          </a:prstGeom>
+          <a:noFill/>
+        </p:spPr>
+        <p:txBody>
+          <a:bodyPr wrap="square" lIns="0" rIns="0" tIns="0" bIns="0">
+            <a:spAutoFit/>
+          </a:bodyPr>
+          <a:lstStyle/>
+          <a:p>
+            <a:pPr algn="l">
+              <a:lnSpc>
+                <a:spcPct val="130000"/>
+              </a:lnSpc>
+            </a:pPr>
+            <a:r>
+              <a:rPr sz="1000" b="0" i="0">
+                <a:solidFill>
+                  <a:srgbClr val="FFD580"/>
+                </a:solidFill>
+                <a:latin typeface="Consolas"/>
+              </a:rPr>
+              <a:t>/api/ayni/[plugin]</a:t>
+            </a:r>
+          </a:p>
+          <a:p>
+            <a:pPr algn="l">
+              <a:lnSpc>
+                <a:spcPct val="130000"/>
+              </a:lnSpc>
+            </a:pPr>
+            <a:r>
+              <a:rPr sz="1000" b="0" i="0">
+                <a:solidFill>
+                  <a:srgbClr val="FFD580"/>
+                </a:solidFill>
+                <a:latin typeface="Consolas"/>
+              </a:rPr>
+              <a:t>MDK · withPayment</a:t>
+            </a:r>
+          </a:p>
+        </p:txBody>
+      </p:sp>
+      <p:sp>
+        <p:nvSpPr>
+          <p:cNvPr id="21" name="Rounded Rectangle 20"/>
+          <p:cNvSpPr/>
+          <p:nvPr/>
+        </p:nvSpPr>
+        <p:spPr>
+          <a:xfrm>
+            <a:off x="3429000" y="4640579"/>
+            <a:ext cx="2377440" cy="1440179"/>
+          </a:xfrm>
+          <a:prstGeom prst="roundRect">
+            <a:avLst>
+              <a:gd name="adj" fmla="val 6000"/>
+            </a:avLst>
+          </a:prstGeom>
+          <a:solidFill>
+            <a:srgbClr val="222D4A"/>
+          </a:solidFill>
+          <a:ln>
+            <a:noFill/>
+          </a:ln>
+        </p:spPr>
+        <p:style>
+          <a:lnRef idx="1">
+            <a:schemeClr val="accent1"/>
+          </a:lnRef>
+          <a:fillRef idx="3">
+            <a:schemeClr val="accent1"/>
+          </a:fillRef>
+          <a:effectRef idx="2">
+            <a:schemeClr val="accent1"/>
+          </a:effectRef>
+          <a:fontRef idx="minor">
+            <a:schemeClr val="lt1"/>
+          </a:fontRef>
+        </p:style>
+        <p:txBody>
+          <a:bodyPr rtlCol="0" anchor="ctr"/>
+          <a:lstStyle/>
+          <a:p>
+            <a:pPr algn="ctr"/>
+          </a:p>
+        </p:txBody>
+      </p:sp>
+      <p:sp>
+        <p:nvSpPr>
+          <p:cNvPr id="22" name="TextBox 21"/>
+          <p:cNvSpPr txBox="1"/>
+          <p:nvPr/>
+        </p:nvSpPr>
+        <p:spPr>
+          <a:xfrm>
+            <a:off x="3611880" y="4777739"/>
+            <a:ext cx="2011680" cy="365760"/>
+          </a:xfrm>
+          <a:prstGeom prst="rect">
+            <a:avLst/>
+          </a:prstGeom>
+          <a:noFill/>
+        </p:spPr>
+        <p:txBody>
+          <a:bodyPr wrap="square" lIns="0" rIns="0" tIns="0" bIns="0">
+            <a:spAutoFit/>
+          </a:bodyPr>
+          <a:lstStyle/>
+          <a:p>
+            <a:pPr algn="l">
+              <a:lnSpc>
+                <a:spcPct val="100000"/>
+              </a:lnSpc>
+            </a:pPr>
+            <a:r>
+              <a:rPr sz="1500" b="1" i="0">
+                <a:solidFill>
+                  <a:srgbClr val="ECECF0"/>
+                </a:solidFill>
+                <a:latin typeface="Calibri"/>
+              </a:rPr>
+              <a:t>splitter</a:t>
+            </a:r>
+          </a:p>
+        </p:txBody>
+      </p:sp>
+      <p:sp>
+        <p:nvSpPr>
+          <p:cNvPr id="23" name="TextBox 22"/>
+          <p:cNvSpPr txBox="1"/>
+          <p:nvPr/>
+        </p:nvSpPr>
+        <p:spPr>
+          <a:xfrm>
+            <a:off x="3611880" y="5143499"/>
+            <a:ext cx="2011680" cy="274320"/>
+          </a:xfrm>
+          <a:prstGeom prst="rect">
+            <a:avLst/>
+          </a:prstGeom>
+          <a:noFill/>
+        </p:spPr>
+        <p:txBody>
+          <a:bodyPr wrap="square" lIns="0" rIns="0" tIns="0" bIns="0">
+            <a:spAutoFit/>
+          </a:bodyPr>
+          <a:lstStyle/>
+          <a:p>
+            <a:pPr algn="l">
+              <a:lnSpc>
+                <a:spcPct val="100000"/>
+              </a:lnSpc>
+            </a:pPr>
+            <a:r>
+              <a:rPr sz="1000" b="0" i="1">
+                <a:solidFill>
+                  <a:srgbClr val="F7931A"/>
+                </a:solidFill>
+                <a:latin typeface="Calibri"/>
+              </a:rPr>
+              <a:t>fan-out</a:t>
+            </a:r>
+          </a:p>
+        </p:txBody>
+      </p:sp>
+      <p:sp>
+        <p:nvSpPr>
+          <p:cNvPr id="24" name="TextBox 23"/>
+          <p:cNvSpPr txBox="1"/>
+          <p:nvPr/>
+        </p:nvSpPr>
+        <p:spPr>
+          <a:xfrm>
+            <a:off x="3611880" y="5417819"/>
+            <a:ext cx="2011680" cy="571499"/>
+          </a:xfrm>
+          <a:prstGeom prst="rect">
+            <a:avLst/>
+          </a:prstGeom>
+          <a:noFill/>
+        </p:spPr>
+        <p:txBody>
+          <a:bodyPr wrap="square" lIns="0" rIns="0" tIns="0" bIns="0">
+            <a:spAutoFit/>
+          </a:bodyPr>
+          <a:lstStyle/>
+          <a:p>
+            <a:pPr algn="l">
+              <a:lnSpc>
+                <a:spcPct val="130000"/>
+              </a:lnSpc>
+            </a:pPr>
+            <a:r>
+              <a:rPr sz="1000" b="0" i="0">
+                <a:solidFill>
+                  <a:srgbClr val="FFD580"/>
+                </a:solidFill>
+                <a:latin typeface="Consolas"/>
+              </a:rPr>
+              <a:t>scripts/demo-flow.sh</a:t>
+            </a:r>
+          </a:p>
+          <a:p>
+            <a:pPr algn="l">
+              <a:lnSpc>
+                <a:spcPct val="130000"/>
+              </a:lnSpc>
+            </a:pPr>
+            <a:r>
+              <a:rPr sz="1000" b="0" i="0">
+                <a:solidFill>
+                  <a:srgbClr val="FFD580"/>
+                </a:solidFill>
+                <a:latin typeface="Consolas"/>
+              </a:rPr>
+              <a:t>floor-then-residual</a:t>
+            </a:r>
+          </a:p>
+        </p:txBody>
+      </p:sp>
+      <p:sp>
+        <p:nvSpPr>
+          <p:cNvPr id="25" name="Rounded Rectangle 24"/>
+          <p:cNvSpPr/>
+          <p:nvPr/>
+        </p:nvSpPr>
+        <p:spPr>
+          <a:xfrm>
+            <a:off x="5989320" y="4640579"/>
+            <a:ext cx="2377440" cy="1440179"/>
+          </a:xfrm>
+          <a:prstGeom prst="roundRect">
+            <a:avLst>
+              <a:gd name="adj" fmla="val 6000"/>
+            </a:avLst>
+          </a:prstGeom>
+          <a:solidFill>
+            <a:srgbClr val="222D4A"/>
+          </a:solidFill>
+          <a:ln>
+            <a:noFill/>
+          </a:ln>
+        </p:spPr>
+        <p:style>
+          <a:lnRef idx="1">
+            <a:schemeClr val="accent1"/>
+          </a:lnRef>
+          <a:fillRef idx="3">
+            <a:schemeClr val="accent1"/>
+          </a:fillRef>
+          <a:effectRef idx="2">
+            <a:schemeClr val="accent1"/>
+          </a:effectRef>
+          <a:fontRef idx="minor">
+            <a:schemeClr val="lt1"/>
+          </a:fontRef>
+        </p:style>
+        <p:txBody>
+          <a:bodyPr rtlCol="0" anchor="ctr"/>
+          <a:lstStyle/>
+          <a:p>
+            <a:pPr algn="ctr"/>
+          </a:p>
+        </p:txBody>
+      </p:sp>
+      <p:sp>
+        <p:nvSpPr>
+          <p:cNvPr id="26" name="TextBox 25"/>
+          <p:cNvSpPr txBox="1"/>
+          <p:nvPr/>
+        </p:nvSpPr>
+        <p:spPr>
+          <a:xfrm>
+            <a:off x="6172200" y="4777739"/>
+            <a:ext cx="2011680" cy="365760"/>
+          </a:xfrm>
+          <a:prstGeom prst="rect">
+            <a:avLst/>
+          </a:prstGeom>
+          <a:noFill/>
+        </p:spPr>
+        <p:txBody>
+          <a:bodyPr wrap="square" lIns="0" rIns="0" tIns="0" bIns="0">
+            <a:spAutoFit/>
+          </a:bodyPr>
+          <a:lstStyle/>
+          <a:p>
+            <a:pPr algn="l">
+              <a:lnSpc>
+                <a:spcPct val="100000"/>
+              </a:lnSpc>
+            </a:pPr>
+            <a:r>
+              <a:rPr sz="1500" b="1" i="0">
+                <a:solidFill>
+                  <a:srgbClr val="ECECF0"/>
+                </a:solidFill>
+                <a:latin typeface="Calibri"/>
+              </a:rPr>
+              <a:t>dashboard</a:t>
+            </a:r>
+          </a:p>
+        </p:txBody>
+      </p:sp>
+      <p:sp>
+        <p:nvSpPr>
+          <p:cNvPr id="27" name="TextBox 26"/>
+          <p:cNvSpPr txBox="1"/>
+          <p:nvPr/>
+        </p:nvSpPr>
+        <p:spPr>
+          <a:xfrm>
+            <a:off x="6172200" y="5143499"/>
+            <a:ext cx="2011680" cy="274320"/>
+          </a:xfrm>
+          <a:prstGeom prst="rect">
+            <a:avLst/>
+          </a:prstGeom>
+          <a:noFill/>
+        </p:spPr>
+        <p:txBody>
+          <a:bodyPr wrap="square" lIns="0" rIns="0" tIns="0" bIns="0">
+            <a:spAutoFit/>
+          </a:bodyPr>
+          <a:lstStyle/>
+          <a:p>
+            <a:pPr algn="l">
+              <a:lnSpc>
+                <a:spcPct val="100000"/>
+              </a:lnSpc>
+            </a:pPr>
+            <a:r>
+              <a:rPr sz="1000" b="0" i="1">
+                <a:solidFill>
+                  <a:srgbClr val="F7931A"/>
+                </a:solidFill>
+                <a:latin typeface="Calibri"/>
+              </a:rPr>
+              <a:t>live UI</a:t>
+            </a:r>
+          </a:p>
+        </p:txBody>
+      </p:sp>
+      <p:sp>
+        <p:nvSpPr>
+          <p:cNvPr id="28" name="TextBox 27"/>
+          <p:cNvSpPr txBox="1"/>
+          <p:nvPr/>
+        </p:nvSpPr>
+        <p:spPr>
+          <a:xfrm>
+            <a:off x="6172200" y="5417819"/>
+            <a:ext cx="2011680" cy="571499"/>
+          </a:xfrm>
+          <a:prstGeom prst="rect">
+            <a:avLst/>
+          </a:prstGeom>
+          <a:noFill/>
+        </p:spPr>
+        <p:txBody>
+          <a:bodyPr wrap="square" lIns="0" rIns="0" tIns="0" bIns="0">
+            <a:spAutoFit/>
+          </a:bodyPr>
+          <a:lstStyle/>
+          <a:p>
+            <a:pPr algn="l">
+              <a:lnSpc>
+                <a:spcPct val="130000"/>
+              </a:lnSpc>
+            </a:pPr>
+            <a:r>
+              <a:rPr sz="1000" b="0" i="0">
+                <a:solidFill>
+                  <a:srgbClr val="FFD580"/>
+                </a:solidFill>
+                <a:latin typeface="Consolas"/>
+              </a:rPr>
+              <a:t>/api/payouts/stream</a:t>
+            </a:r>
+          </a:p>
+          <a:p>
+            <a:pPr algn="l">
+              <a:lnSpc>
+                <a:spcPct val="130000"/>
+              </a:lnSpc>
+            </a:pPr>
+            <a:r>
+              <a:rPr sz="1000" b="0" i="0">
+                <a:solidFill>
+                  <a:srgbClr val="FFD580"/>
+                </a:solidFill>
+                <a:latin typeface="Consolas"/>
+              </a:rPr>
+              <a:t>SSE  ·  2-phase</a:t>
+            </a:r>
+          </a:p>
+        </p:txBody>
+      </p:sp>
+      <p:sp>
+        <p:nvSpPr>
+          <p:cNvPr id="29" name="Rounded Rectangle 28"/>
+          <p:cNvSpPr/>
+          <p:nvPr/>
+        </p:nvSpPr>
+        <p:spPr>
+          <a:xfrm>
+            <a:off x="9144000" y="2331720"/>
+            <a:ext cx="2468880" cy="1783080"/>
           </a:xfrm>
           <a:prstGeom prst="roundRect">
             <a:avLst>
@@ -3742,14 +4595,14 @@
       </p:sp>
       <p:sp>
         <p:nvSpPr>
-          <p:cNvPr id="11" name="TextBox 10"/>
+          <p:cNvPr id="30" name="TextBox 29"/>
           <p:cNvSpPr txBox="1"/>
           <p:nvPr/>
         </p:nvSpPr>
         <p:spPr>
           <a:xfrm>
-            <a:off x="6643116" y="3063240"/>
-            <a:ext cx="4631436" cy="640080"/>
+            <a:off x="9144000" y="2560320"/>
+            <a:ext cx="2468880" cy="457200"/>
           </a:xfrm>
           <a:prstGeom prst="rect">
             <a:avLst/>
@@ -3762,33 +4615,33 @@
           </a:bodyPr>
           <a:lstStyle/>
           <a:p>
-            <a:pPr algn="l">
+            <a:pPr algn="ctr">
               <a:lnSpc>
                 <a:spcPct val="100000"/>
               </a:lnSpc>
             </a:pPr>
             <a:r>
-              <a:rPr sz="3000" b="1" i="0">
+              <a:rPr sz="2000" b="1" i="0">
                 <a:solidFill>
                   <a:srgbClr val="F7931A"/>
                 </a:solidFill>
                 <a:latin typeface="Calibri"/>
               </a:rPr>
-              <a:t>MoneyDevKit 0.16</a:t>
-            </a:r>
-          </a:p>
-        </p:txBody>
-      </p:sp>
-      <p:sp>
-        <p:nvSpPr>
-          <p:cNvPr id="12" name="TextBox 11"/>
+              <a:t>Lightning</a:t>
+            </a:r>
+          </a:p>
+        </p:txBody>
+      </p:sp>
+      <p:sp>
+        <p:nvSpPr>
+          <p:cNvPr id="31" name="TextBox 30"/>
           <p:cNvSpPr txBox="1"/>
           <p:nvPr/>
         </p:nvSpPr>
         <p:spPr>
           <a:xfrm>
-            <a:off x="6643116" y="3703320"/>
-            <a:ext cx="4631436" cy="457200"/>
+            <a:off x="9144000" y="3063240"/>
+            <a:ext cx="2468880" cy="365760"/>
           </a:xfrm>
           <a:prstGeom prst="rect">
             <a:avLst/>
@@ -3801,7 +4654,7 @@
           </a:bodyPr>
           <a:lstStyle/>
           <a:p>
-            <a:pPr algn="l">
+            <a:pPr algn="ctr">
               <a:lnSpc>
                 <a:spcPct val="100000"/>
               </a:lnSpc>
@@ -3809,25 +4662,64 @@
             <a:r>
               <a:rPr sz="1400" b="0" i="0">
                 <a:solidFill>
+                  <a:srgbClr val="ECECF0"/>
+                </a:solidFill>
+                <a:latin typeface="Calibri"/>
+              </a:rPr>
+              <a:t>Bitcoin mainnet</a:t>
+            </a:r>
+          </a:p>
+        </p:txBody>
+      </p:sp>
+      <p:sp>
+        <p:nvSpPr>
+          <p:cNvPr id="32" name="TextBox 31"/>
+          <p:cNvSpPr txBox="1"/>
+          <p:nvPr/>
+        </p:nvSpPr>
+        <p:spPr>
+          <a:xfrm>
+            <a:off x="9144000" y="3474720"/>
+            <a:ext cx="2468880" cy="365760"/>
+          </a:xfrm>
+          <a:prstGeom prst="rect">
+            <a:avLst/>
+          </a:prstGeom>
+          <a:noFill/>
+        </p:spPr>
+        <p:txBody>
+          <a:bodyPr wrap="square" lIns="0" rIns="0" tIns="0" bIns="0">
+            <a:spAutoFit/>
+          </a:bodyPr>
+          <a:lstStyle/>
+          <a:p>
+            <a:pPr algn="ctr">
+              <a:lnSpc>
+                <a:spcPct val="100000"/>
+              </a:lnSpc>
+            </a:pPr>
+            <a:r>
+              <a:rPr sz="1100" b="0" i="0">
+                <a:solidFill>
                   <a:srgbClr val="8B93A7"/>
                 </a:solidFill>
                 <a:latin typeface="Consolas"/>
               </a:rPr>
-              <a:t>@moneydevkit/nextjs · withPayment</a:t>
-            </a:r>
-          </a:p>
-        </p:txBody>
-      </p:sp>
-      <p:sp>
-        <p:nvSpPr>
-          <p:cNvPr id="13" name="Rounded Rectangle 12"/>
+              <a:t>BOLT11 invoices</a:t>
+            </a:r>
+          </a:p>
+        </p:txBody>
+      </p:sp>
+      <p:sp>
+        <p:nvSpPr>
+          <p:cNvPr id="33" name="Rounded Rectangle 32"/>
           <p:cNvSpPr/>
           <p:nvPr/>
         </p:nvSpPr>
         <p:spPr>
           <a:xfrm>
-            <a:off x="548640" y="4572000"/>
-            <a:ext cx="5362956" cy="1463040"/>
+            <a:off x="9144000" y="4343400"/>
+            <a:ext cx="2468880" cy="1920240"/>
           </a:xfrm>
           <a:prstGeom prst="roundRect">
             <a:avLst>
@@ -3865,14 +4757,14 @@
       </p:sp>
       <p:sp>
         <p:nvSpPr>
-          <p:cNvPr id="14" name="TextBox 13"/>
+          <p:cNvPr id="34" name="TextBox 33"/>
           <p:cNvSpPr txBox="1"/>
           <p:nvPr/>
         </p:nvSpPr>
         <p:spPr>
           <a:xfrm>
-            <a:off x="914400" y="4800600"/>
-            <a:ext cx="4631436" cy="640080"/>
+            <a:off x="9144000" y="4526280"/>
+            <a:ext cx="2468880" cy="457200"/>
           </a:xfrm>
           <a:prstGeom prst="rect">
             <a:avLst/>
@@ -3885,33 +4777,33 @@
           </a:bodyPr>
           <a:lstStyle/>
           <a:p>
-            <a:pPr algn="l">
+            <a:pPr algn="ctr">
               <a:lnSpc>
                 <a:spcPct val="100000"/>
               </a:lnSpc>
             </a:pPr>
             <a:r>
-              <a:rPr sz="3000" b="1" i="0">
+              <a:rPr sz="1800" b="1" i="0">
                 <a:solidFill>
                   <a:srgbClr val="F7931A"/>
                 </a:solidFill>
                 <a:latin typeface="Calibri"/>
               </a:rPr>
-              <a:t>L402</a:t>
-            </a:r>
-          </a:p>
-        </p:txBody>
-      </p:sp>
-      <p:sp>
-        <p:nvSpPr>
-          <p:cNvPr id="15" name="TextBox 14"/>
+              <a:t>Contributors</a:t>
+            </a:r>
+          </a:p>
+        </p:txBody>
+      </p:sp>
+      <p:sp>
+        <p:nvSpPr>
+          <p:cNvPr id="35" name="TextBox 34"/>
           <p:cNvSpPr txBox="1"/>
           <p:nvPr/>
         </p:nvSpPr>
         <p:spPr>
           <a:xfrm>
-            <a:off x="914400" y="5440680"/>
-            <a:ext cx="4631436" cy="457200"/>
+            <a:off x="9144000" y="5029200"/>
+            <a:ext cx="2468880" cy="365760"/>
           </a:xfrm>
           <a:prstGeom prst="rect">
             <a:avLst/>
@@ -3924,41 +4816,39 @@
           </a:bodyPr>
           <a:lstStyle/>
           <a:p>
-            <a:pPr algn="l">
+            <a:pPr algn="ctr">
               <a:lnSpc>
                 <a:spcPct val="100000"/>
               </a:lnSpc>
             </a:pPr>
             <a:r>
-              <a:rPr sz="1400" b="0" i="0">
-                <a:solidFill>
-                  <a:srgbClr val="8B93A7"/>
+              <a:rPr sz="1100" b="0" i="0">
+                <a:solidFill>
+                  <a:srgbClr val="ECECF0"/>
                 </a:solidFill>
                 <a:latin typeface="Consolas"/>
               </a:rPr>
-              <a:t>HTTP 402 + Lightning invoice + macaroon</a:t>
-            </a:r>
-          </a:p>
-        </p:txBody>
-      </p:sp>
-      <p:sp>
-        <p:nvSpPr>
-          <p:cNvPr id="16" name="Rounded Rectangle 15"/>
+              <a:t>BOLT12  /  LN-Address</a:t>
+            </a:r>
+          </a:p>
+        </p:txBody>
+      </p:sp>
+      <p:sp>
+        <p:nvSpPr>
+          <p:cNvPr id="36" name="Oval 35"/>
           <p:cNvSpPr/>
           <p:nvPr/>
         </p:nvSpPr>
         <p:spPr>
           <a:xfrm>
-            <a:off x="6277356" y="4572000"/>
-            <a:ext cx="5362956" cy="1463040"/>
-          </a:xfrm>
-          <a:prstGeom prst="roundRect">
-            <a:avLst>
-              <a:gd name="adj" fmla="val 6000"/>
-            </a:avLst>
+            <a:off x="9363456" y="5577840"/>
+            <a:ext cx="310896" cy="310896"/>
+          </a:xfrm>
+          <a:prstGeom prst="ellipse">
+            <a:avLst/>
           </a:prstGeom>
           <a:solidFill>
-            <a:srgbClr val="182138"/>
+            <a:srgbClr val="FFD580"/>
           </a:solidFill>
           <a:ln>
             <a:noFill/>
@@ -3988,14 +4878,229 @@
       </p:sp>
       <p:sp>
         <p:nvSpPr>
-          <p:cNvPr id="17" name="TextBox 16"/>
+          <p:cNvPr id="37" name="Oval 36"/>
+          <p:cNvSpPr/>
+          <p:nvPr/>
+        </p:nvSpPr>
+        <p:spPr>
+          <a:xfrm>
+            <a:off x="9793224" y="5577840"/>
+            <a:ext cx="310896" cy="310896"/>
+          </a:xfrm>
+          <a:prstGeom prst="ellipse">
+            <a:avLst/>
+          </a:prstGeom>
+          <a:solidFill>
+            <a:srgbClr val="FFD580"/>
+          </a:solidFill>
+          <a:ln>
+            <a:noFill/>
+          </a:ln>
+        </p:spPr>
+        <p:style>
+          <a:lnRef idx="1">
+            <a:schemeClr val="accent1"/>
+          </a:lnRef>
+          <a:fillRef idx="3">
+            <a:schemeClr val="accent1"/>
+          </a:fillRef>
+          <a:effectRef idx="2">
+            <a:schemeClr val="accent1"/>
+          </a:effectRef>
+          <a:fontRef idx="minor">
+            <a:schemeClr val="lt1"/>
+          </a:fontRef>
+        </p:style>
+        <p:txBody>
+          <a:bodyPr rtlCol="0" anchor="ctr"/>
+          <a:lstStyle/>
+          <a:p>
+            <a:pPr algn="ctr"/>
+          </a:p>
+        </p:txBody>
+      </p:sp>
+      <p:sp>
+        <p:nvSpPr>
+          <p:cNvPr id="38" name="Oval 37"/>
+          <p:cNvSpPr/>
+          <p:nvPr/>
+        </p:nvSpPr>
+        <p:spPr>
+          <a:xfrm>
+            <a:off x="10222992" y="5577840"/>
+            <a:ext cx="310896" cy="310896"/>
+          </a:xfrm>
+          <a:prstGeom prst="ellipse">
+            <a:avLst/>
+          </a:prstGeom>
+          <a:solidFill>
+            <a:srgbClr val="FFD580"/>
+          </a:solidFill>
+          <a:ln>
+            <a:noFill/>
+          </a:ln>
+        </p:spPr>
+        <p:style>
+          <a:lnRef idx="1">
+            <a:schemeClr val="accent1"/>
+          </a:lnRef>
+          <a:fillRef idx="3">
+            <a:schemeClr val="accent1"/>
+          </a:fillRef>
+          <a:effectRef idx="2">
+            <a:schemeClr val="accent1"/>
+          </a:effectRef>
+          <a:fontRef idx="minor">
+            <a:schemeClr val="lt1"/>
+          </a:fontRef>
+        </p:style>
+        <p:txBody>
+          <a:bodyPr rtlCol="0" anchor="ctr"/>
+          <a:lstStyle/>
+          <a:p>
+            <a:pPr algn="ctr"/>
+          </a:p>
+        </p:txBody>
+      </p:sp>
+      <p:sp>
+        <p:nvSpPr>
+          <p:cNvPr id="39" name="Oval 38"/>
+          <p:cNvSpPr/>
+          <p:nvPr/>
+        </p:nvSpPr>
+        <p:spPr>
+          <a:xfrm>
+            <a:off x="10652760" y="5577840"/>
+            <a:ext cx="310896" cy="310896"/>
+          </a:xfrm>
+          <a:prstGeom prst="ellipse">
+            <a:avLst/>
+          </a:prstGeom>
+          <a:solidFill>
+            <a:srgbClr val="FFD580"/>
+          </a:solidFill>
+          <a:ln>
+            <a:noFill/>
+          </a:ln>
+        </p:spPr>
+        <p:style>
+          <a:lnRef idx="1">
+            <a:schemeClr val="accent1"/>
+          </a:lnRef>
+          <a:fillRef idx="3">
+            <a:schemeClr val="accent1"/>
+          </a:fillRef>
+          <a:effectRef idx="2">
+            <a:schemeClr val="accent1"/>
+          </a:effectRef>
+          <a:fontRef idx="minor">
+            <a:schemeClr val="lt1"/>
+          </a:fontRef>
+        </p:style>
+        <p:txBody>
+          <a:bodyPr rtlCol="0" anchor="ctr"/>
+          <a:lstStyle/>
+          <a:p>
+            <a:pPr algn="ctr"/>
+          </a:p>
+        </p:txBody>
+      </p:sp>
+      <p:sp>
+        <p:nvSpPr>
+          <p:cNvPr id="40" name="Oval 39"/>
+          <p:cNvSpPr/>
+          <p:nvPr/>
+        </p:nvSpPr>
+        <p:spPr>
+          <a:xfrm>
+            <a:off x="11082528" y="5577840"/>
+            <a:ext cx="310896" cy="310896"/>
+          </a:xfrm>
+          <a:prstGeom prst="ellipse">
+            <a:avLst/>
+          </a:prstGeom>
+          <a:solidFill>
+            <a:srgbClr val="FFD580"/>
+          </a:solidFill>
+          <a:ln>
+            <a:noFill/>
+          </a:ln>
+        </p:spPr>
+        <p:style>
+          <a:lnRef idx="1">
+            <a:schemeClr val="accent1"/>
+          </a:lnRef>
+          <a:fillRef idx="3">
+            <a:schemeClr val="accent1"/>
+          </a:fillRef>
+          <a:effectRef idx="2">
+            <a:schemeClr val="accent1"/>
+          </a:effectRef>
+          <a:fontRef idx="minor">
+            <a:schemeClr val="lt1"/>
+          </a:fontRef>
+        </p:style>
+        <p:txBody>
+          <a:bodyPr rtlCol="0" anchor="ctr"/>
+          <a:lstStyle/>
+          <a:p>
+            <a:pPr algn="ctr"/>
+          </a:p>
+        </p:txBody>
+      </p:sp>
+      <p:sp>
+        <p:nvSpPr>
+          <p:cNvPr id="41" name="Right Arrow 40"/>
+          <p:cNvSpPr/>
+          <p:nvPr/>
+        </p:nvSpPr>
+        <p:spPr>
+          <a:xfrm>
+            <a:off x="2697480" y="4160520"/>
+            <a:ext cx="365760" cy="292608"/>
+          </a:xfrm>
+          <a:prstGeom prst="rightArrow">
+            <a:avLst/>
+          </a:prstGeom>
+          <a:solidFill>
+            <a:srgbClr val="F7931A"/>
+          </a:solidFill>
+          <a:ln>
+            <a:noFill/>
+          </a:ln>
+        </p:spPr>
+        <p:style>
+          <a:lnRef idx="1">
+            <a:schemeClr val="accent1"/>
+          </a:lnRef>
+          <a:fillRef idx="3">
+            <a:schemeClr val="accent1"/>
+          </a:fillRef>
+          <a:effectRef idx="2">
+            <a:schemeClr val="accent1"/>
+          </a:effectRef>
+          <a:fontRef idx="minor">
+            <a:schemeClr val="lt1"/>
+          </a:fontRef>
+        </p:style>
+        <p:txBody>
+          <a:bodyPr rtlCol="0" anchor="ctr"/>
+          <a:lstStyle/>
+          <a:p>
+            <a:pPr algn="ctr"/>
+          </a:p>
+        </p:txBody>
+      </p:sp>
+      <p:sp>
+        <p:nvSpPr>
+          <p:cNvPr id="42" name="TextBox 41"/>
           <p:cNvSpPr txBox="1"/>
           <p:nvPr/>
         </p:nvSpPr>
         <p:spPr>
           <a:xfrm>
-            <a:off x="6643116" y="4800600"/>
-            <a:ext cx="4631436" cy="640080"/>
+            <a:off x="2651760" y="3794760"/>
+            <a:ext cx="457200" cy="274320"/>
           </a:xfrm>
           <a:prstGeom prst="rect">
             <a:avLst/>
@@ -4008,33 +5113,33 @@
           </a:bodyPr>
           <a:lstStyle/>
           <a:p>
-            <a:pPr algn="l">
+            <a:pPr algn="ctr">
               <a:lnSpc>
                 <a:spcPct val="100000"/>
               </a:lnSpc>
             </a:pPr>
             <a:r>
-              <a:rPr sz="3000" b="1" i="0">
-                <a:solidFill>
-                  <a:srgbClr val="F7931A"/>
+              <a:rPr sz="1000" b="1" i="0">
+                <a:solidFill>
+                  <a:srgbClr val="ECECF0"/>
                 </a:solidFill>
                 <a:latin typeface="Calibri"/>
               </a:rPr>
-              <a:t>Bitcoin mainnet</a:t>
-            </a:r>
-          </a:p>
-        </p:txBody>
-      </p:sp>
-      <p:sp>
-        <p:nvSpPr>
-          <p:cNvPr id="18" name="TextBox 17"/>
+              <a:t>1.  call</a:t>
+            </a:r>
+          </a:p>
+        </p:txBody>
+      </p:sp>
+      <p:sp>
+        <p:nvSpPr>
+          <p:cNvPr id="43" name="TextBox 42"/>
           <p:cNvSpPr txBox="1"/>
           <p:nvPr/>
         </p:nvSpPr>
         <p:spPr>
           <a:xfrm>
-            <a:off x="6643116" y="5440680"/>
-            <a:ext cx="4631436" cy="457200"/>
+            <a:off x="2651760" y="4480560"/>
+            <a:ext cx="457200" cy="274320"/>
           </a:xfrm>
           <a:prstGeom prst="rect">
             <a:avLst/>
@@ -4047,19 +5152,261 @@
           </a:bodyPr>
           <a:lstStyle/>
           <a:p>
-            <a:pPr algn="l">
+            <a:pPr algn="ctr">
               <a:lnSpc>
                 <a:spcPct val="100000"/>
               </a:lnSpc>
             </a:pPr>
             <a:r>
-              <a:rPr sz="1400" b="0" i="0">
+              <a:rPr sz="900" b="0" i="0">
                 <a:solidFill>
                   <a:srgbClr val="8B93A7"/>
                 </a:solidFill>
-                <a:latin typeface="Consolas"/>
-              </a:rPr>
-              <a:t>BOLT11 / BOLT12 · real sats</a:t>
+                <a:latin typeface="Calibri"/>
+              </a:rPr>
+              <a:t>← answer</a:t>
+            </a:r>
+          </a:p>
+        </p:txBody>
+      </p:sp>
+      <p:sp>
+        <p:nvSpPr>
+          <p:cNvPr id="44" name="Right Arrow 43"/>
+          <p:cNvSpPr/>
+          <p:nvPr/>
+        </p:nvSpPr>
+        <p:spPr>
+          <a:xfrm>
+            <a:off x="8641080" y="3108960"/>
+            <a:ext cx="365760" cy="292608"/>
+          </a:xfrm>
+          <a:prstGeom prst="rightArrow">
+            <a:avLst/>
+          </a:prstGeom>
+          <a:solidFill>
+            <a:srgbClr val="F7931A"/>
+          </a:solidFill>
+          <a:ln>
+            <a:noFill/>
+          </a:ln>
+        </p:spPr>
+        <p:style>
+          <a:lnRef idx="1">
+            <a:schemeClr val="accent1"/>
+          </a:lnRef>
+          <a:fillRef idx="3">
+            <a:schemeClr val="accent1"/>
+          </a:fillRef>
+          <a:effectRef idx="2">
+            <a:schemeClr val="accent1"/>
+          </a:effectRef>
+          <a:fontRef idx="minor">
+            <a:schemeClr val="lt1"/>
+          </a:fontRef>
+        </p:style>
+        <p:txBody>
+          <a:bodyPr rtlCol="0" anchor="ctr"/>
+          <a:lstStyle/>
+          <a:p>
+            <a:pPr algn="ctr"/>
+          </a:p>
+        </p:txBody>
+      </p:sp>
+      <p:sp>
+        <p:nvSpPr>
+          <p:cNvPr id="45" name="TextBox 44"/>
+          <p:cNvSpPr txBox="1"/>
+          <p:nvPr/>
+        </p:nvSpPr>
+        <p:spPr>
+          <a:xfrm>
+            <a:off x="8595360" y="2743200"/>
+            <a:ext cx="457200" cy="274320"/>
+          </a:xfrm>
+          <a:prstGeom prst="rect">
+            <a:avLst/>
+          </a:prstGeom>
+          <a:noFill/>
+        </p:spPr>
+        <p:txBody>
+          <a:bodyPr wrap="square" lIns="0" rIns="0" tIns="0" bIns="0">
+            <a:spAutoFit/>
+          </a:bodyPr>
+          <a:lstStyle/>
+          <a:p>
+            <a:pPr algn="ctr">
+              <a:lnSpc>
+                <a:spcPct val="100000"/>
+              </a:lnSpc>
+            </a:pPr>
+            <a:r>
+              <a:rPr sz="900" b="1" i="0">
+                <a:solidFill>
+                  <a:srgbClr val="ECECF0"/>
+                </a:solidFill>
+                <a:latin typeface="Calibri"/>
+              </a:rPr>
+              <a:t>2.  invoice</a:t>
+            </a:r>
+          </a:p>
+        </p:txBody>
+      </p:sp>
+      <p:sp>
+        <p:nvSpPr>
+          <p:cNvPr id="46" name="TextBox 45"/>
+          <p:cNvSpPr txBox="1"/>
+          <p:nvPr/>
+        </p:nvSpPr>
+        <p:spPr>
+          <a:xfrm>
+            <a:off x="8595360" y="3429000"/>
+            <a:ext cx="457200" cy="274320"/>
+          </a:xfrm>
+          <a:prstGeom prst="rect">
+            <a:avLst/>
+          </a:prstGeom>
+          <a:noFill/>
+        </p:spPr>
+        <p:txBody>
+          <a:bodyPr wrap="square" lIns="0" rIns="0" tIns="0" bIns="0">
+            <a:spAutoFit/>
+          </a:bodyPr>
+          <a:lstStyle/>
+          <a:p>
+            <a:pPr algn="ctr">
+              <a:lnSpc>
+                <a:spcPct val="100000"/>
+              </a:lnSpc>
+            </a:pPr>
+            <a:r>
+              <a:rPr sz="800" b="0" i="0">
+                <a:solidFill>
+                  <a:srgbClr val="8B93A7"/>
+                </a:solidFill>
+                <a:latin typeface="Calibri"/>
+              </a:rPr>
+              <a:t>← preimage</a:t>
+            </a:r>
+          </a:p>
+        </p:txBody>
+      </p:sp>
+      <p:sp>
+        <p:nvSpPr>
+          <p:cNvPr id="47" name="Right Arrow 46"/>
+          <p:cNvSpPr/>
+          <p:nvPr/>
+        </p:nvSpPr>
+        <p:spPr>
+          <a:xfrm>
+            <a:off x="8641080" y="5212080"/>
+            <a:ext cx="365760" cy="292608"/>
+          </a:xfrm>
+          <a:prstGeom prst="rightArrow">
+            <a:avLst/>
+          </a:prstGeom>
+          <a:solidFill>
+            <a:srgbClr val="F7931A"/>
+          </a:solidFill>
+          <a:ln>
+            <a:noFill/>
+          </a:ln>
+        </p:spPr>
+        <p:style>
+          <a:lnRef idx="1">
+            <a:schemeClr val="accent1"/>
+          </a:lnRef>
+          <a:fillRef idx="3">
+            <a:schemeClr val="accent1"/>
+          </a:fillRef>
+          <a:effectRef idx="2">
+            <a:schemeClr val="accent1"/>
+          </a:effectRef>
+          <a:fontRef idx="minor">
+            <a:schemeClr val="lt1"/>
+          </a:fontRef>
+        </p:style>
+        <p:txBody>
+          <a:bodyPr rtlCol="0" anchor="ctr"/>
+          <a:lstStyle/>
+          <a:p>
+            <a:pPr algn="ctr"/>
+          </a:p>
+        </p:txBody>
+      </p:sp>
+      <p:sp>
+        <p:nvSpPr>
+          <p:cNvPr id="48" name="TextBox 47"/>
+          <p:cNvSpPr txBox="1"/>
+          <p:nvPr/>
+        </p:nvSpPr>
+        <p:spPr>
+          <a:xfrm>
+            <a:off x="8595360" y="4846320"/>
+            <a:ext cx="457200" cy="274320"/>
+          </a:xfrm>
+          <a:prstGeom prst="rect">
+            <a:avLst/>
+          </a:prstGeom>
+          <a:noFill/>
+        </p:spPr>
+        <p:txBody>
+          <a:bodyPr wrap="square" lIns="0" rIns="0" tIns="0" bIns="0">
+            <a:spAutoFit/>
+          </a:bodyPr>
+          <a:lstStyle/>
+          <a:p>
+            <a:pPr algn="ctr">
+              <a:lnSpc>
+                <a:spcPct val="100000"/>
+              </a:lnSpc>
+            </a:pPr>
+            <a:r>
+              <a:rPr sz="900" b="1" i="0">
+                <a:solidFill>
+                  <a:srgbClr val="ECECF0"/>
+                </a:solidFill>
+                <a:latin typeface="Calibri"/>
+              </a:rPr>
+              <a:t>3.  fan-out</a:t>
+            </a:r>
+          </a:p>
+        </p:txBody>
+      </p:sp>
+      <p:sp>
+        <p:nvSpPr>
+          <p:cNvPr id="49" name="TextBox 48"/>
+          <p:cNvSpPr txBox="1"/>
+          <p:nvPr/>
+        </p:nvSpPr>
+        <p:spPr>
+          <a:xfrm>
+            <a:off x="548640" y="6400800"/>
+            <a:ext cx="11091672" cy="365760"/>
+          </a:xfrm>
+          <a:prstGeom prst="rect">
+            <a:avLst/>
+          </a:prstGeom>
+          <a:noFill/>
+        </p:spPr>
+        <p:txBody>
+          <a:bodyPr wrap="square" lIns="0" rIns="0" tIns="0" bIns="0">
+            <a:spAutoFit/>
+          </a:bodyPr>
+          <a:lstStyle/>
+          <a:p>
+            <a:pPr algn="ctr">
+              <a:lnSpc>
+                <a:spcPct val="100000"/>
+              </a:lnSpc>
+            </a:pPr>
+            <a:r>
+              <a:rPr sz="1100" b="0" i="1">
+                <a:solidFill>
+                  <a:srgbClr val="FFD580"/>
+                </a:solidFill>
+                <a:latin typeface="Calibri"/>
+              </a:rPr>
+              <a:t>(1) agent calls API   →   (2) MDK issues + verifies Lightning invoice   →   (3) splitter fans out to all contributors</a:t>
             </a:r>
           </a:p>
         </p:txBody>
@@ -4169,7 +5516,7 @@
                 </a:solidFill>
                 <a:latin typeface="Consolas"/>
               </a:rPr>
-              <a:t>0:18 – 0:28</a:t>
+              <a:t>0:25 – 0:35</a:t>
             </a:r>
           </a:p>
         </p:txBody>
@@ -4226,7 +5573,7 @@
         <p:spPr>
           <a:xfrm>
             <a:off x="777240" y="640080"/>
-            <a:ext cx="4572000" cy="457200"/>
+            <a:ext cx="5486400" cy="457200"/>
           </a:xfrm>
           <a:prstGeom prst="rect">
             <a:avLst/>
@@ -4251,7 +5598,7 @@
                 </a:solidFill>
                 <a:latin typeface="Calibri"/>
               </a:rPr>
-              <a:t>ARCHITECTURE</a:t>
+              <a:t>L402 ZOOM</a:t>
             </a:r>
           </a:p>
         </p:txBody>
@@ -4290,7 +5637,7 @@
                 </a:solidFill>
                 <a:latin typeface="Calibri"/>
               </a:rPr>
-              <a:t>The L402 request flow.</a:t>
+              <a:t>Inside the API route.</a:t>
             </a:r>
           </a:p>
         </p:txBody>
@@ -5280,7 +6627,7 @@
                 </a:solidFill>
                 <a:latin typeface="Consolas"/>
               </a:rPr>
-              <a:t>0:28 – 0:42</a:t>
+              <a:t>0:35 – 0:46</a:t>
             </a:r>
           </a:p>
         </p:txBody>
@@ -5337,7 +6684,7 @@
         <p:spPr>
           <a:xfrm>
             <a:off x="777240" y="640080"/>
-            <a:ext cx="4572000" cy="457200"/>
+            <a:ext cx="5486400" cy="457200"/>
           </a:xfrm>
           <a:prstGeom prst="rect">
             <a:avLst/>
@@ -6298,7 +7645,7 @@
                 </a:solidFill>
                 <a:latin typeface="Consolas"/>
               </a:rPr>
-              <a:t>0:42 – 0:55</a:t>
+              <a:t>0:46 – 0:55</a:t>
             </a:r>
           </a:p>
         </p:txBody>
@@ -6355,7 +7702,7 @@
         <p:spPr>
           <a:xfrm>
             <a:off x="777240" y="640080"/>
-            <a:ext cx="4572000" cy="457200"/>
+            <a:ext cx="5486400" cy="457200"/>
           </a:xfrm>
           <a:prstGeom prst="rect">
             <a:avLst/>

</xml_diff>